<commit_message>
Speed 2b: real-network numbers (NN 0.0013ms; closed-form ODE now faster than NN)
Co-Authored-By: Claude Opus 4.8 <noreply@anthropic.com>
</commit_message>
<xml_diff>
--- a/en_primeur_lab_meeting.pptx
+++ b/en_primeur_lab_meeting.pptx
@@ -3112,7 +3112,7 @@
         </p:nvSpPr>
         <p:spPr>
           <a:xfrm>
-            <a:off x="640080" y="640080"/>
+            <a:off x="640080" y="594360"/>
             <a:ext cx="10972800" cy="822960"/>
           </a:xfrm>
           <a:prstGeom prst="rect">
@@ -3129,7 +3129,7 @@
               <a:buNone/>
             </a:pPr>
             <a:r>
-              <a:rPr lang="en-US" sz="3200" b="1" dirty="0">
+              <a:rPr lang="en-US" sz="3400" b="1" dirty="0">
                 <a:solidFill>
                   <a:srgbClr val="F3ECD8"/>
                 </a:solidFill>
@@ -3137,9 +3137,9 @@
                 <a:ea typeface="Cambria" pitchFamily="34" charset="-122"/>
                 <a:cs typeface="Cambria" pitchFamily="34" charset="-120"/>
               </a:rPr>
-              <a:t>What the speed really means</a:t>
+              <a:t>Why it matters</a:t>
             </a:r>
-            <a:endParaRPr lang="en-US" sz="3200" dirty="0"/>
+            <a:endParaRPr lang="en-US" sz="3400" dirty="0"/>
           </a:p>
         </p:txBody>
       </p:sp>
@@ -3151,8 +3151,8 @@
         </p:nvSpPr>
         <p:spPr>
           <a:xfrm>
-            <a:off x="640080" y="1828800"/>
-            <a:ext cx="5029200" cy="1463040"/>
+            <a:off x="640080" y="1737360"/>
+            <a:ext cx="5120640" cy="731520"/>
           </a:xfrm>
           <a:prstGeom prst="rect">
             <a:avLst/>
@@ -3168,7 +3168,7 @@
               <a:buNone/>
             </a:pPr>
             <a:r>
-              <a:rPr lang="en-US" sz="9600" b="1" dirty="0">
+              <a:rPr lang="en-US" sz="3000" b="1" dirty="0">
                 <a:solidFill>
                   <a:srgbClr val="A2823E"/>
                 </a:solidFill>
@@ -3176,9 +3176,9 @@
                 <a:ea typeface="Cambria" pitchFamily="34" charset="-122"/>
                 <a:cs typeface="Cambria" pitchFamily="34" charset="-120"/>
               </a:rPr>
-              <a:t>~50×</a:t>
+              <a:t>Media design</a:t>
             </a:r>
-            <a:endParaRPr lang="en-US" sz="9600" dirty="0"/>
+            <a:endParaRPr lang="en-US" sz="3000" dirty="0"/>
           </a:p>
         </p:txBody>
       </p:sp>
@@ -3190,8 +3190,8 @@
         </p:nvSpPr>
         <p:spPr>
           <a:xfrm>
-            <a:off x="640080" y="3383280"/>
-            <a:ext cx="5120640" cy="1463040"/>
+            <a:off x="640080" y="2514600"/>
+            <a:ext cx="5120640" cy="3017520"/>
           </a:xfrm>
           <a:prstGeom prst="rect">
             <a:avLst/>
@@ -3205,7 +3205,7 @@
           <a:p>
             <a:pPr algn="l" indent="0" marL="0">
               <a:lnSpc>
-                <a:spcPct val="120000"/>
+                <a:spcPct val="125000"/>
               </a:lnSpc>
               <a:buNone/>
             </a:pPr>
@@ -3218,33 +3218,8 @@
                 <a:ea typeface="Calibri" pitchFamily="34" charset="-122"/>
                 <a:cs typeface="Calibri" pitchFamily="34" charset="-120"/>
               </a:rPr>
-              <a:t>faster than a fair GPU solver on this simplified ODE, where the exact solution is already cheap.</a:t>
+              <a:t>A model that predicts state change better than random has </a:t>
             </a:r>
-            <a:endParaRPr lang="en-US" sz="1800" dirty="0"/>
-          </a:p>
-        </p:txBody>
-      </p:sp>
-      <p:sp>
-        <p:nvSpPr>
-          <p:cNvPr id="5" name="Text 3"/>
-          <p:cNvSpPr/>
-          <p:nvPr/>
-        </p:nvSpPr>
-        <p:spPr>
-          <a:xfrm>
-            <a:off x="6400800" y="1920240"/>
-            <a:ext cx="5212080" cy="3200400"/>
-          </a:xfrm>
-          <a:prstGeom prst="rect">
-            <a:avLst/>
-          </a:prstGeom>
-          <a:noFill/>
-          <a:ln/>
-        </p:spPr>
-        <p:txBody>
-          <a:bodyPr wrap="square" lIns="0" tIns="0" rIns="0" bIns="0" rtlCol="0" anchor="t"/>
-          <a:lstStyle/>
-          <a:p>
             <a:pPr algn="l" indent="0" marL="0">
               <a:lnSpc>
                 <a:spcPct val="125000"/>
@@ -3252,16 +3227,15 @@
               <a:buNone/>
             </a:pPr>
             <a:r>
-              <a:rPr lang="en-US" sz="2000" b="1" dirty="0">
+              <a:rPr lang="en-US" sz="1800" b="1" dirty="0">
                 <a:solidFill>
-                  <a:srgbClr val="A2823E"/>
+                  <a:srgbClr val="F3ECD8"/>
                 </a:solidFill>
                 <a:latin typeface="Calibri" pitchFamily="34" charset="0"/>
                 <a:ea typeface="Calibri" pitchFamily="34" charset="-122"/>
                 <a:cs typeface="Calibri" pitchFamily="34" charset="-120"/>
               </a:rPr>
-              <a:t>The durable reason for a surrogate
-</a:t>
+              <a:t>learned what drives it.</a:t>
             </a:r>
             <a:pPr algn="l" indent="0" marL="0">
               <a:lnSpc>
@@ -3278,7 +3252,88 @@
                 <a:ea typeface="Calibri" pitchFamily="34" charset="-122"/>
                 <a:cs typeface="Calibri" pitchFamily="34" charset="-120"/>
               </a:rPr>
-              <a:t>is mechanistic models with </a:t>
+              <a:t> Read those importances out (sensitivity, attention, SHAP) and you get which conditions and media components matter. This does not depend on speed.</a:t>
+            </a:r>
+            <a:endParaRPr lang="en-US" sz="1800" dirty="0"/>
+          </a:p>
+        </p:txBody>
+      </p:sp>
+      <p:sp>
+        <p:nvSpPr>
+          <p:cNvPr id="5" name="Text 3"/>
+          <p:cNvSpPr/>
+          <p:nvPr/>
+        </p:nvSpPr>
+        <p:spPr>
+          <a:xfrm>
+            <a:off x="6400800" y="1737360"/>
+            <a:ext cx="5120640" cy="731520"/>
+          </a:xfrm>
+          <a:prstGeom prst="rect">
+            <a:avLst/>
+          </a:prstGeom>
+          <a:noFill/>
+          <a:ln/>
+        </p:spPr>
+        <p:txBody>
+          <a:bodyPr wrap="square" lIns="0" tIns="0" rIns="0" bIns="0" rtlCol="0" anchor="ctr"/>
+          <a:lstStyle/>
+          <a:p>
+            <a:pPr algn="l" indent="0" marL="0">
+              <a:buNone/>
+            </a:pPr>
+            <a:r>
+              <a:rPr lang="en-US" sz="3000" b="1" dirty="0">
+                <a:solidFill>
+                  <a:srgbClr val="A2823E"/>
+                </a:solidFill>
+                <a:latin typeface="Cambria" pitchFamily="34" charset="0"/>
+                <a:ea typeface="Cambria" pitchFamily="34" charset="-122"/>
+                <a:cs typeface="Cambria" pitchFamily="34" charset="-120"/>
+              </a:rPr>
+              <a:t>Speed, conditional</a:t>
+            </a:r>
+            <a:endParaRPr lang="en-US" sz="3000" dirty="0"/>
+          </a:p>
+        </p:txBody>
+      </p:sp>
+      <p:sp>
+        <p:nvSpPr>
+          <p:cNvPr id="6" name="Text 4"/>
+          <p:cNvSpPr/>
+          <p:nvPr/>
+        </p:nvSpPr>
+        <p:spPr>
+          <a:xfrm>
+            <a:off x="6400800" y="2514600"/>
+            <a:ext cx="5120640" cy="3017520"/>
+          </a:xfrm>
+          <a:prstGeom prst="rect">
+            <a:avLst/>
+          </a:prstGeom>
+          <a:noFill/>
+          <a:ln/>
+        </p:spPr>
+        <p:txBody>
+          <a:bodyPr wrap="square" lIns="0" tIns="0" rIns="0" bIns="0" rtlCol="0" anchor="t"/>
+          <a:lstStyle/>
+          <a:p>
+            <a:pPr algn="l" indent="0" marL="0">
+              <a:lnSpc>
+                <a:spcPct val="125000"/>
+              </a:lnSpc>
+              <a:buNone/>
+            </a:pPr>
+            <a:r>
+              <a:rPr lang="en-US" sz="1800" dirty="0">
+                <a:solidFill>
+                  <a:srgbClr val="F3ECD8"/>
+                </a:solidFill>
+                <a:latin typeface="Calibri" pitchFamily="34" charset="0"/>
+                <a:ea typeface="Calibri" pitchFamily="34" charset="-122"/>
+                <a:cs typeface="Calibri" pitchFamily="34" charset="-120"/>
+              </a:rPr>
+              <a:t>Faster than solving the ODE, but the margin depends on the solver. The </a:t>
             </a:r>
             <a:pPr algn="l" indent="0" marL="0">
               <a:lnSpc>
@@ -3295,7 +3350,7 @@
                 <a:ea typeface="Calibri" pitchFamily="34" charset="-122"/>
                 <a:cs typeface="Calibri" pitchFamily="34" charset="-120"/>
               </a:rPr>
-              <a:t>no closed form</a:t>
+              <a:t>durable</a:t>
             </a:r>
             <a:pPr algn="l" indent="0" marL="0">
               <a:lnSpc>
@@ -3312,7 +3367,7 @@
                 <a:ea typeface="Calibri" pitchFamily="34" charset="-122"/>
                 <a:cs typeface="Calibri" pitchFamily="34" charset="-120"/>
               </a:rPr>
-              <a:t> (the full flux-balance COSMIC-dFBA), where a general solver like torchdiffeq pays a ~2,000× penalty the NN avoids.</a:t>
+              <a:t> win is mechanistic models with no closed form (the full flux-balance COSMIC-dFBA), where a general solver pays a ~2,000× penalty the NN avoids.</a:t>
             </a:r>
             <a:endParaRPr lang="en-US" sz="1800" dirty="0"/>
           </a:p>
@@ -4483,7 +4538,7 @@
                 <a:ea typeface="Calibri" pitchFamily="34" charset="-122"/>
                 <a:cs typeface="Calibri" pitchFamily="34" charset="-120"/>
               </a:rPr>
-              <a:t>Hybrid: ODE in the forward pass, keep the MSE loss, report generate-vs-predict timing (started).</a:t>
+              <a:t>Lazy training: add data for each new condition as it is encountered and retrain (~4 min). The hard part is detecting out-of-distribution inputs, knowing when to add.</a:t>
             </a:r>
             <a:endParaRPr lang="en-US" sz="1450" dirty="0"/>
           </a:p>
@@ -4545,7 +4600,7 @@
                 <a:ea typeface="Calibri" pitchFamily="34" charset="-122"/>
                 <a:cs typeface="Calibri" pitchFamily="34" charset="-120"/>
               </a:rPr>
-              <a:t>Continuous-time PINN (differential form of the physics penalty).</a:t>
+              <a:t>Hybrid ODE-in-forward inference timing; continuous-time PINN.</a:t>
             </a:r>
             <a:endParaRPr lang="en-US" sz="1450" dirty="0"/>
           </a:p>
@@ -9566,7 +9621,7 @@
                 <a:ea typeface="Cambria" pitchFamily="34" charset="-122"/>
                 <a:cs typeface="Cambria" pitchFamily="34" charset="-120"/>
               </a:rPr>
-              <a:t>You were right #2: was the speed test fair?</a:t>
+              <a:t>Inference: NN vs generating the run</a:t>
             </a:r>
             <a:endParaRPr lang="en-US" sz="3200" dirty="0"/>
           </a:p>
@@ -9581,7 +9636,7 @@
         <p:spPr>
           <a:xfrm>
             <a:off x="548640" y="1508760"/>
-            <a:ext cx="5394960" cy="1828800"/>
+            <a:ext cx="5394960" cy="1920240"/>
           </a:xfrm>
           <a:prstGeom prst="rect">
             <a:avLst/>
@@ -9608,7 +9663,7 @@
                 <a:ea typeface="Calibri" pitchFamily="34" charset="-122"/>
                 <a:cs typeface="Calibri" pitchFamily="34" charset="-120"/>
               </a:rPr>
-              <a:t>The old “3,000×” compared a CPU solver against a batched GPU network, mostly a hardware difference. We re-timed every method the same way and on the same device, and added </a:t>
+              <a:t>Generating a run = solving the ODE, and that IS the mechanistic model (predictive, just not neural). We time NN inference against it, same device where we can. </a:t>
             </a:r>
             <a:pPr algn="l" indent="0" marL="0">
               <a:lnSpc>
@@ -9625,7 +9680,7 @@
                 <a:ea typeface="Calibri" pitchFamily="34" charset="-122"/>
                 <a:cs typeface="Calibri" pitchFamily="34" charset="-120"/>
               </a:rPr>
-              <a:t>torchdiffeq</a:t>
+              <a:t>scipy is CPU-only</a:t>
             </a:r>
             <a:pPr algn="l" indent="0" marL="0">
               <a:lnSpc>
@@ -9642,7 +9697,7 @@
                 <a:ea typeface="Calibri" pitchFamily="34" charset="-122"/>
                 <a:cs typeface="Calibri" pitchFamily="34" charset="-120"/>
               </a:rPr>
-              <a:t> as a fair GPU-solver baseline.</a:t>
+              <a:t>; the fair on-GPU baselines are torchdiffeq and the exact closed-form step.</a:t>
             </a:r>
             <a:endParaRPr lang="en-US" sz="1600" dirty="0"/>
           </a:p>
@@ -9657,7 +9712,7 @@
         <p:spPr>
           <a:xfrm>
             <a:off x="548640" y="3657600"/>
-            <a:ext cx="5394960" cy="1463040"/>
+            <a:ext cx="5394960" cy="1554480"/>
           </a:xfrm>
           <a:prstGeom prst="rect">
             <a:avLst/>
@@ -9701,7 +9756,7 @@
                 <a:ea typeface="Calibri" pitchFamily="34" charset="-122"/>
                 <a:cs typeface="Calibri" pitchFamily="34" charset="-120"/>
               </a:rPr>
-              <a:t>Against a fair GPU solver the NN is ~50× faster, not 100,000×. The rest was scipy being CPU-bound.</a:t>
+              <a:t>Thousands of times faster than a general solver, but only ~2–3× faster than the exact closed-form step on the same GPU. Our ODE is simple enough to have a closed form; the big win is for models that do not.</a:t>
             </a:r>
             <a:endParaRPr lang="en-US" sz="1600" dirty="0"/>
           </a:p>

</xml_diff>

<commit_message>
Add --conv-layers flag to nn_baseline (accuracy-vs-depth ablation)
Co-Authored-By: Claude Opus 4.8 <noreply@anthropic.com>
</commit_message>
<xml_diff>
--- a/en_primeur_lab_meeting.pptx
+++ b/en_primeur_lab_meeting.pptx
@@ -9756,7 +9756,7 @@
                 <a:ea typeface="Calibri" pitchFamily="34" charset="-122"/>
                 <a:cs typeface="Calibri" pitchFamily="34" charset="-120"/>
               </a:rPr>
-              <a:t>Thousands of times faster than a general solver, but only ~2–3× faster than the exact closed-form step on the same GPU. Our ODE is simple enough to have a closed form; the big win is for models that do not.</a:t>
+              <a:t>On this ODE the exact closed-form solve on the GPU is actually faster than the NN. The NN only beats a general solver (~9.5×); the huge scipy number is hardware. Speed is not the win here.</a:t>
             </a:r>
             <a:endParaRPr lang="en-US" sz="1600" dirty="0"/>
           </a:p>
@@ -9785,10 +9785,10 @@
             <a:tbl>
               <a:tblPr/>
               <a:tblGrid>
-                <a:gridCol w="2560320"/>
+                <a:gridCol w="2651760"/>
                 <a:gridCol w="1005840"/>
-                <a:gridCol w="868680"/>
-                <a:gridCol w="868680"/>
+                <a:gridCol w="822960"/>
+                <a:gridCol w="822960"/>
               </a:tblGrid>
               <a:tr h="566928">
                 <a:tc>
@@ -10150,7 +10150,7 @@
                           <a:ea typeface="Calibri" pitchFamily="34" charset="-122"/>
                           <a:cs typeface="Calibri" pitchFamily="34" charset="-120"/>
                         </a:rPr>
-                        <a:t>25.06</a:t>
+                        <a:t>25.25</a:t>
                       </a:r>
                       <a:endParaRPr lang="en-US" sz="1250" dirty="0">
                         <a:latin typeface="Calibri" charset="0"/>
@@ -10424,7 +10424,7 @@
                           <a:ea typeface="Calibri" pitchFamily="34" charset="-122"/>
                           <a:cs typeface="Calibri" pitchFamily="34" charset="-120"/>
                         </a:rPr>
-                        <a:t>0.012</a:t>
+                        <a:t>0.013</a:t>
                       </a:r>
                       <a:endParaRPr lang="en-US" sz="1250" dirty="0">
                         <a:latin typeface="Calibri" charset="0"/>
@@ -10622,9 +10622,9 @@
                         <a:buNone/>
                       </a:pPr>
                       <a:r>
-                        <a:rPr lang="en-US" sz="1250" dirty="0">
+                        <a:rPr lang="en-US" sz="1250" b="1" dirty="0">
                           <a:solidFill>
-                            <a:srgbClr val="2B211A"/>
+                            <a:srgbClr val="3A4A2E"/>
                           </a:solidFill>
                           <a:latin typeface="Calibri" pitchFamily="34" charset="0"/>
                           <a:ea typeface="Calibri" pitchFamily="34" charset="-122"/>
@@ -10690,9 +10690,9 @@
                         <a:buNone/>
                       </a:pPr>
                       <a:r>
-                        <a:rPr lang="en-US" sz="1250" dirty="0">
+                        <a:rPr lang="en-US" sz="1250" b="1" dirty="0">
                           <a:solidFill>
-                            <a:srgbClr val="2B211A"/>
+                            <a:srgbClr val="3A4A2E"/>
                           </a:solidFill>
                           <a:latin typeface="Calibri" pitchFamily="34" charset="0"/>
                           <a:ea typeface="Calibri" pitchFamily="34" charset="-122"/>
@@ -10758,9 +10758,9 @@
                         <a:buNone/>
                       </a:pPr>
                       <a:r>
-                        <a:rPr lang="en-US" sz="1250" dirty="0">
+                        <a:rPr lang="en-US" sz="1250" b="1" dirty="0">
                           <a:solidFill>
-                            <a:srgbClr val="2B211A"/>
+                            <a:srgbClr val="3A4A2E"/>
                           </a:solidFill>
                           <a:latin typeface="Calibri" pitchFamily="34" charset="0"/>
                           <a:ea typeface="Calibri" pitchFamily="34" charset="-122"/>
@@ -10826,15 +10826,15 @@
                         <a:buNone/>
                       </a:pPr>
                       <a:r>
-                        <a:rPr lang="en-US" sz="1250" dirty="0">
+                        <a:rPr lang="en-US" sz="1250" b="1" dirty="0">
                           <a:solidFill>
-                            <a:srgbClr val="2B211A"/>
+                            <a:srgbClr val="3A4A2E"/>
                           </a:solidFill>
                           <a:latin typeface="Calibri" pitchFamily="34" charset="0"/>
                           <a:ea typeface="Calibri" pitchFamily="34" charset="-122"/>
                           <a:cs typeface="Calibri" pitchFamily="34" charset="-120"/>
                         </a:rPr>
-                        <a:t>23×</a:t>
+                        <a:t>24×</a:t>
                       </a:r>
                       <a:endParaRPr lang="en-US" sz="1250" dirty="0">
                         <a:latin typeface="Calibri" charset="0"/>
@@ -10904,7 +10904,7 @@
                           <a:ea typeface="Calibri" pitchFamily="34" charset="-122"/>
                           <a:cs typeface="Calibri" pitchFamily="34" charset="-120"/>
                         </a:rPr>
-                        <a:t>pure NN (GPU)</a:t>
+                        <a:t>pure NN (GPU, real net)</a:t>
                       </a:r>
                       <a:endParaRPr lang="en-US" sz="1250" dirty="0">
                         <a:latin typeface="Calibri" charset="0"/>
@@ -10972,7 +10972,7 @@
                           <a:ea typeface="Calibri" pitchFamily="34" charset="-122"/>
                           <a:cs typeface="Calibri" pitchFamily="34" charset="-120"/>
                         </a:rPr>
-                        <a:t>0.0002</a:t>
+                        <a:t>0.0013</a:t>
                       </a:r>
                       <a:endParaRPr lang="en-US" sz="1250" dirty="0">
                         <a:latin typeface="Calibri" charset="0"/>
@@ -11040,7 +11040,7 @@
                           <a:ea typeface="Calibri" pitchFamily="34" charset="-122"/>
                           <a:cs typeface="Calibri" pitchFamily="34" charset="-120"/>
                         </a:rPr>
-                        <a:t>103,000×</a:t>
+                        <a:t>18,900×</a:t>
                       </a:r>
                       <a:endParaRPr lang="en-US" sz="1250" dirty="0">
                         <a:latin typeface="Calibri" charset="0"/>
@@ -11108,7 +11108,7 @@
                           <a:ea typeface="Calibri" pitchFamily="34" charset="-122"/>
                           <a:cs typeface="Calibri" pitchFamily="34" charset="-120"/>
                         </a:rPr>
-                        <a:t>50×</a:t>
+                        <a:t>9.5×</a:t>
                       </a:r>
                       <a:endParaRPr lang="en-US" sz="1250" dirty="0">
                         <a:latin typeface="Calibri" charset="0"/>
@@ -11172,8 +11172,8 @@
         </p:nvSpPr>
         <p:spPr>
           <a:xfrm>
-            <a:off x="6400800" y="5212080"/>
-            <a:ext cx="5303520" cy="365760"/>
+            <a:off x="6400800" y="5166360"/>
+            <a:ext cx="5303520" cy="640080"/>
           </a:xfrm>
           <a:prstGeom prst="rect">
             <a:avLst/>
@@ -11182,14 +11182,14 @@
           <a:ln/>
         </p:spPr>
         <p:txBody>
-          <a:bodyPr wrap="square" lIns="0" tIns="0" rIns="0" bIns="0" rtlCol="0" anchor="ctr"/>
+          <a:bodyPr wrap="square" lIns="0" tIns="0" rIns="0" bIns="0" rtlCol="0" anchor="t"/>
           <a:lstStyle/>
           <a:p>
             <a:pPr algn="l" indent="0" marL="0">
               <a:buNone/>
             </a:pPr>
             <a:r>
-              <a:rPr lang="en-US" sz="1200" i="1" dirty="0">
+              <a:rPr lang="en-US" sz="1100" i="1" dirty="0">
                 <a:solidFill>
                   <a:srgbClr val="7A6E5A"/>
                 </a:solidFill>
@@ -11197,9 +11197,9 @@
                 <a:ea typeface="Calibri" pitchFamily="34" charset="-122"/>
                 <a:cs typeface="Calibri" pitchFamily="34" charset="-120"/>
               </a:rPr>
-              <a:t>A100, n = 20,000, timed in a sustained loop.</a:t>
+              <a:t>A100, n = 20,000, sustained loop. NN = real model (hidden 64, 3 conv). Green: the closed-form ODE beats the NN.</a:t>
             </a:r>
-            <a:endParaRPr lang="en-US" sz="1200" dirty="0"/>
+            <a:endParaRPr lang="en-US" sz="1100" dirty="0"/>
           </a:p>
         </p:txBody>
       </p:sp>

</xml_diff>

<commit_message>
Adopt small model (1 conv, hidden 32) per Kimberly; add resolution + ablation notes
Co-Authored-By: Claude Opus 4.8 <noreply@anthropic.com>
</commit_message>
<xml_diff>
--- a/en_primeur_lab_meeting.pptx
+++ b/en_primeur_lab_meeting.pptx
@@ -3291,7 +3291,7 @@
                 <a:ea typeface="Cambria" pitchFamily="34" charset="-122"/>
                 <a:cs typeface="Cambria" pitchFamily="34" charset="-120"/>
               </a:rPr>
-              <a:t>Speed, conditional</a:t>
+              <a:t>Real-time monitoring</a:t>
             </a:r>
             <a:endParaRPr lang="en-US" sz="3000" dirty="0"/>
           </a:p>
@@ -3306,7 +3306,7 @@
         <p:spPr>
           <a:xfrm>
             <a:off x="6400800" y="2514600"/>
-            <a:ext cx="5120640" cy="3017520"/>
+            <a:ext cx="5120640" cy="3108960"/>
           </a:xfrm>
           <a:prstGeom prst="rect">
             <a:avLst/>
@@ -3320,12 +3320,12 @@
           <a:p>
             <a:pPr algn="l" indent="0" marL="0">
               <a:lnSpc>
-                <a:spcPct val="125000"/>
+                <a:spcPct val="120000"/>
               </a:lnSpc>
               <a:buNone/>
             </a:pPr>
             <a:r>
-              <a:rPr lang="en-US" sz="1800" dirty="0">
+              <a:rPr lang="en-US" sz="1700" dirty="0">
                 <a:solidFill>
                   <a:srgbClr val="F3ECD8"/>
                 </a:solidFill>
@@ -3333,16 +3333,16 @@
                 <a:ea typeface="Calibri" pitchFamily="34" charset="-122"/>
                 <a:cs typeface="Calibri" pitchFamily="34" charset="-120"/>
               </a:rPr>
-              <a:t>Faster than solving the ODE, but the margin depends on the solver. The </a:t>
+              <a:t>A fast, interpretable surrogate enables Process Analytical Technology and Real-Time Release Testing, prediction and explanation </a:t>
             </a:r>
             <a:pPr algn="l" indent="0" marL="0">
               <a:lnSpc>
-                <a:spcPct val="125000"/>
+                <a:spcPct val="120000"/>
               </a:lnSpc>
               <a:buNone/>
             </a:pPr>
             <a:r>
-              <a:rPr lang="en-US" sz="1800" b="1" dirty="0">
+              <a:rPr lang="en-US" sz="1700" b="1" dirty="0">
                 <a:solidFill>
                   <a:srgbClr val="F3ECD8"/>
                 </a:solidFill>
@@ -3350,16 +3350,16 @@
                 <a:ea typeface="Calibri" pitchFamily="34" charset="-122"/>
                 <a:cs typeface="Calibri" pitchFamily="34" charset="-120"/>
               </a:rPr>
-              <a:t>durable</a:t>
+              <a:t>during</a:t>
             </a:r>
             <a:pPr algn="l" indent="0" marL="0">
               <a:lnSpc>
-                <a:spcPct val="125000"/>
+                <a:spcPct val="120000"/>
               </a:lnSpc>
               <a:buNone/>
             </a:pPr>
             <a:r>
-              <a:rPr lang="en-US" sz="1800" dirty="0">
+              <a:rPr lang="en-US" sz="1700" dirty="0">
                 <a:solidFill>
                   <a:srgbClr val="F3ECD8"/>
                 </a:solidFill>
@@ -3367,9 +3367,38 @@
                 <a:ea typeface="Calibri" pitchFamily="34" charset="-122"/>
                 <a:cs typeface="Calibri" pitchFamily="34" charset="-120"/>
               </a:rPr>
-              <a:t> win is mechanistic models with no closed form (the full flux-balance COSMIC-dFBA), where a general solver pays a ~2,000× penalty the NN avoids.</a:t>
-            </a:r>
-            <a:endParaRPr lang="en-US" sz="1800" dirty="0"/>
+              <a:t> a run, not offline.</a:t>
+            </a:r>
+            <a:endParaRPr lang="en-US" sz="1700" dirty="0"/>
+          </a:p>
+          <a:p>
+            <a:pPr algn="l" indent="0" marL="0">
+              <a:lnSpc>
+                <a:spcPct val="120000"/>
+              </a:lnSpc>
+              <a:buNone/>
+            </a:pPr>
+            <a:endParaRPr lang="en-US" sz="1700" dirty="0"/>
+          </a:p>
+          <a:p>
+            <a:pPr algn="l" indent="0" marL="0">
+              <a:lnSpc>
+                <a:spcPct val="120000"/>
+              </a:lnSpc>
+              <a:buNone/>
+            </a:pPr>
+            <a:r>
+              <a:rPr lang="en-US" sz="1700" dirty="0">
+                <a:solidFill>
+                  <a:srgbClr val="F3ECD8"/>
+                </a:solidFill>
+                <a:latin typeface="Calibri" pitchFamily="34" charset="0"/>
+                <a:ea typeface="Calibri" pitchFamily="34" charset="-122"/>
+                <a:cs typeface="Calibri" pitchFamily="34" charset="-120"/>
+              </a:rPr>
+              <a:t>Precedent: Patel &amp; Patel (2026) use SHAP on Raman spectra to find the drivers of glucose and acetate, toward PAT/RTRT.</a:t>
+            </a:r>
+            <a:endParaRPr lang="en-US" sz="1700" dirty="0"/>
           </a:p>
         </p:txBody>
       </p:sp>
@@ -6890,7 +6919,7 @@
                           <a:ea typeface="Calibri" pitchFamily="34" charset="-122"/>
                           <a:cs typeface="Calibri" pitchFamily="34" charset="-120"/>
                         </a:rPr>
-                        <a:t>0.99</a:t>
+                        <a:t>0.98</a:t>
                       </a:r>
                       <a:endParaRPr lang="en-US" sz="1300" dirty="0">
                         <a:latin typeface="Calibri" charset="0"/>
@@ -6958,7 +6987,7 @@
                           <a:ea typeface="Calibri" pitchFamily="34" charset="-122"/>
                           <a:cs typeface="Calibri" pitchFamily="34" charset="-120"/>
                         </a:rPr>
-                        <a:t>0.77</a:t>
+                        <a:t>0.91</a:t>
                       </a:r>
                       <a:endParaRPr lang="en-US" sz="1300" dirty="0">
                         <a:latin typeface="Calibri" charset="0"/>
@@ -7416,7 +7445,7 @@
                           <a:ea typeface="Calibri" pitchFamily="34" charset="-122"/>
                           <a:cs typeface="Calibri" pitchFamily="34" charset="-120"/>
                         </a:rPr>
-                        <a:t>0.97</a:t>
+                        <a:t>0.95</a:t>
                       </a:r>
                       <a:endParaRPr lang="en-US" sz="1300" dirty="0">
                         <a:latin typeface="Calibri" charset="0"/>
@@ -7484,7 +7513,7 @@
                           <a:ea typeface="Calibri" pitchFamily="34" charset="-122"/>
                           <a:cs typeface="Calibri" pitchFamily="34" charset="-120"/>
                         </a:rPr>
-                        <a:t>0.98</a:t>
+                        <a:t>0.97</a:t>
                       </a:r>
                       <a:endParaRPr lang="en-US" sz="1300" dirty="0">
                         <a:latin typeface="Calibri" charset="0"/>
@@ -7690,7 +7719,7 @@
                           <a:ea typeface="Calibri" pitchFamily="34" charset="-122"/>
                           <a:cs typeface="Calibri" pitchFamily="34" charset="-120"/>
                         </a:rPr>
-                        <a:t>1.00</a:t>
+                        <a:t>0.99</a:t>
                       </a:r>
                       <a:endParaRPr lang="en-US" sz="1300" dirty="0">
                         <a:latin typeface="Calibri" charset="0"/>
@@ -7758,7 +7787,7 @@
                           <a:ea typeface="Calibri" pitchFamily="34" charset="-122"/>
                           <a:cs typeface="Calibri" pitchFamily="34" charset="-120"/>
                         </a:rPr>
-                        <a:t>0.95</a:t>
+                        <a:t>0.97</a:t>
                       </a:r>
                       <a:endParaRPr lang="en-US" sz="1300" dirty="0">
                         <a:latin typeface="Calibri" charset="0"/>
@@ -7953,7 +7982,7 @@
                           <a:ea typeface="Calibri" pitchFamily="34" charset="-122"/>
                           <a:cs typeface="Calibri" pitchFamily="34" charset="-120"/>
                         </a:rPr>
-                        <a:t>0.97</a:t>
+                        <a:t>0.95</a:t>
                       </a:r>
                       <a:endParaRPr lang="en-US" sz="1300" dirty="0">
                         <a:latin typeface="Calibri" charset="0"/>
@@ -8021,7 +8050,7 @@
                           <a:ea typeface="Calibri" pitchFamily="34" charset="-122"/>
                           <a:cs typeface="Calibri" pitchFamily="34" charset="-120"/>
                         </a:rPr>
-                        <a:t>0.69</a:t>
+                        <a:t>0.53</a:t>
                       </a:r>
                       <a:endParaRPr lang="en-US" sz="1300" dirty="0">
                         <a:latin typeface="Calibri" charset="0"/>
@@ -8284,7 +8313,7 @@
                           <a:ea typeface="Calibri" pitchFamily="34" charset="-122"/>
                           <a:cs typeface="Calibri" pitchFamily="34" charset="-120"/>
                         </a:rPr>
-                        <a:t>0.79</a:t>
+                        <a:t>0.62</a:t>
                       </a:r>
                       <a:endParaRPr lang="en-US" sz="1300" dirty="0">
                         <a:latin typeface="Calibri" charset="0"/>
@@ -8547,7 +8576,7 @@
                           <a:ea typeface="Calibri" pitchFamily="34" charset="-122"/>
                           <a:cs typeface="Calibri" pitchFamily="34" charset="-120"/>
                         </a:rPr>
-                        <a:t>0.86</a:t>
+                        <a:t>0.63</a:t>
                       </a:r>
                       <a:endParaRPr lang="en-US" sz="1300" dirty="0">
                         <a:latin typeface="Calibri" charset="0"/>
@@ -8821,7 +8850,7 @@
                           <a:ea typeface="Calibri" pitchFamily="34" charset="-122"/>
                           <a:cs typeface="Calibri" pitchFamily="34" charset="-120"/>
                         </a:rPr>
-                        <a:t>0.51</a:t>
+                        <a:t>0.49</a:t>
                       </a:r>
                       <a:endParaRPr lang="en-US" sz="1300" dirty="0">
                         <a:latin typeface="Calibri" charset="0"/>
@@ -8953,8 +8982,8 @@
         </p:nvSpPr>
         <p:spPr>
           <a:xfrm>
-            <a:off x="6400800" y="5989320"/>
-            <a:ext cx="5212080" cy="365760"/>
+            <a:off x="6400800" y="5943600"/>
+            <a:ext cx="5212080" cy="548640"/>
           </a:xfrm>
           <a:prstGeom prst="rect">
             <a:avLst/>
@@ -8963,14 +8992,14 @@
           <a:ln/>
         </p:spPr>
         <p:txBody>
-          <a:bodyPr wrap="square" lIns="0" tIns="0" rIns="0" bIns="0" rtlCol="0" anchor="ctr"/>
+          <a:bodyPr wrap="square" lIns="0" tIns="0" rIns="0" bIns="0" rtlCol="0" anchor="t"/>
           <a:lstStyle/>
           <a:p>
             <a:pPr algn="l" indent="0" marL="0">
               <a:buNone/>
             </a:pPr>
             <a:r>
-              <a:rPr lang="en-US" sz="1200" i="1" dirty="0">
+              <a:rPr lang="en-US" sz="1100" i="1" dirty="0">
                 <a:solidFill>
                   <a:srgbClr val="7A6E5A"/>
                 </a:solidFill>
@@ -8978,9 +9007,9 @@
                 <a:ea typeface="Calibri" pitchFamily="34" charset="-122"/>
                 <a:cs typeface="Calibri" pitchFamily="34" charset="-120"/>
               </a:rPr>
-              <a:t>5 of 8 score R² 0.97–1.00; the amino acids read n/a only on the flat-window rule.</a:t>
-            </a:r>
-            <a:endParaRPr lang="en-US" sz="1200" dirty="0"/>
+              <a:t>5 of 8 score R² 0.95–0.99 (small model: 1 conv layer, hidden 32, chosen for xAI). Amino acids read n/a on the flat-window rule.</a:t>
+            </a:r>
+            <a:endParaRPr lang="en-US" sz="1100" dirty="0"/>
           </a:p>
         </p:txBody>
       </p:sp>
@@ -9057,7 +9086,7 @@
       </p:sp>
       <p:pic>
         <p:nvPicPr>
-          <p:cNvPr id="3" name="Image 0" descr="/Users/nevecallaway/code/COSMIC-dFBA-nn/figures/nn_baseline_parity_6.png">    </p:cNvPr>
+          <p:cNvPr id="3" name="Image 0" descr="/Users/nevecallaway/code/COSMIC-dFBA-nn/figures/nn_baseline_parity_final.png">    </p:cNvPr>
           <p:cNvPicPr>
             <a:picLocks noChangeAspect="1"/>
           </p:cNvPicPr>
@@ -9211,7 +9240,7 @@
       </p:sp>
       <p:pic>
         <p:nvPicPr>
-          <p:cNvPr id="3" name="Image 0" descr="/Users/nevecallaway/code/COSMIC-dFBA-nn/figures/nn_baseline_r2_Titer_6.png">    </p:cNvPr>
+          <p:cNvPr id="3" name="Image 0" descr="/Users/nevecallaway/code/COSMIC-dFBA-nn/figures/nn_baseline_r2_Titer_final.png">    </p:cNvPr>
           <p:cNvPicPr>
             <a:picLocks noChangeAspect="1"/>
           </p:cNvPicPr>
@@ -9621,7 +9650,7 @@
                 <a:ea typeface="Cambria" pitchFamily="34" charset="-122"/>
                 <a:cs typeface="Cambria" pitchFamily="34" charset="-120"/>
               </a:rPr>
-              <a:t>Inference: NN vs generating the run</a:t>
+              <a:t>Inference: NN vs the mechanistic model</a:t>
             </a:r>
             <a:endParaRPr lang="en-US" sz="3200" dirty="0"/>
           </a:p>
@@ -9635,8 +9664,47 @@
         </p:nvSpPr>
         <p:spPr>
           <a:xfrm>
-            <a:off x="548640" y="1508760"/>
-            <a:ext cx="5394960" cy="1920240"/>
+            <a:off x="548640" y="1463040"/>
+            <a:ext cx="5486400" cy="731520"/>
+          </a:xfrm>
+          <a:prstGeom prst="rect">
+            <a:avLst/>
+          </a:prstGeom>
+          <a:noFill/>
+          <a:ln/>
+        </p:spPr>
+        <p:txBody>
+          <a:bodyPr wrap="square" lIns="0" tIns="0" rIns="0" bIns="0" rtlCol="0" anchor="ctr"/>
+          <a:lstStyle/>
+          <a:p>
+            <a:pPr algn="l" indent="0" marL="0">
+              <a:buNone/>
+            </a:pPr>
+            <a:r>
+              <a:rPr lang="en-US" sz="3000" b="1" dirty="0">
+                <a:solidFill>
+                  <a:srgbClr val="6B2333"/>
+                </a:solidFill>
+                <a:latin typeface="Cambria" pitchFamily="34" charset="0"/>
+                <a:ea typeface="Cambria" pitchFamily="34" charset="-122"/>
+                <a:cs typeface="Cambria" pitchFamily="34" charset="-120"/>
+              </a:rPr>
+              <a:t>~15 min  →  0.0013 ms</a:t>
+            </a:r>
+            <a:endParaRPr lang="en-US" sz="3000" dirty="0"/>
+          </a:p>
+        </p:txBody>
+      </p:sp>
+      <p:sp>
+        <p:nvSpPr>
+          <p:cNvPr id="4" name="Text 2"/>
+          <p:cNvSpPr/>
+          <p:nvPr/>
+        </p:nvSpPr>
+        <p:spPr>
+          <a:xfrm>
+            <a:off x="548640" y="2286000"/>
+            <a:ext cx="5486400" cy="1463040"/>
           </a:xfrm>
           <a:prstGeom prst="rect">
             <a:avLst/>
@@ -9663,7 +9731,7 @@
                 <a:ea typeface="Calibri" pitchFamily="34" charset="-122"/>
                 <a:cs typeface="Calibri" pitchFamily="34" charset="-120"/>
               </a:rPr>
-              <a:t>Generating a run = solving the ODE, and that IS the mechanistic model (predictive, just not neural). We time NN inference against it, same device where we can. </a:t>
+              <a:t>COSMIC-dFBA takes </a:t>
             </a:r>
             <a:pPr algn="l" indent="0" marL="0">
               <a:lnSpc>
@@ -9680,7 +9748,7 @@
                 <a:ea typeface="Calibri" pitchFamily="34" charset="-122"/>
                 <a:cs typeface="Calibri" pitchFamily="34" charset="-120"/>
               </a:rPr>
-              <a:t>scipy is CPU-only</a:t>
+              <a:t>~15 minutes per reactor</a:t>
             </a:r>
             <a:pPr algn="l" indent="0" marL="0">
               <a:lnSpc>
@@ -9697,7 +9765,7 @@
                 <a:ea typeface="Calibri" pitchFamily="34" charset="-122"/>
                 <a:cs typeface="Calibri" pitchFamily="34" charset="-120"/>
               </a:rPr>
-              <a:t>; the fair on-GPU baselines are torchdiffeq and the exact closed-form step.</a:t>
+              <a:t> (Sarat: 3.7 GHz CPU, no parallelization, 1-day resolution). The NN predicts the same run in 0.0013 ms, hundreds of millions of times faster.</a:t>
             </a:r>
             <a:endParaRPr lang="en-US" sz="1600" dirty="0"/>
           </a:p>
@@ -9705,14 +9773,14 @@
       </p:sp>
       <p:sp>
         <p:nvSpPr>
-          <p:cNvPr id="4" name="Text 2"/>
+          <p:cNvPr id="5" name="Text 3"/>
           <p:cNvSpPr/>
           <p:nvPr/>
         </p:nvSpPr>
         <p:spPr>
           <a:xfrm>
-            <a:off x="548640" y="3657600"/>
-            <a:ext cx="5394960" cy="1554480"/>
+            <a:off x="548640" y="3794760"/>
+            <a:ext cx="5486400" cy="1554480"/>
           </a:xfrm>
           <a:prstGeom prst="rect">
             <a:avLst/>
@@ -9726,12 +9794,12 @@
           <a:p>
             <a:pPr algn="l" indent="0" marL="0">
               <a:lnSpc>
-                <a:spcPct val="120000"/>
+                <a:spcPct val="115000"/>
               </a:lnSpc>
               <a:buNone/>
             </a:pPr>
             <a:r>
-              <a:rPr lang="en-US" sz="1600" b="1" dirty="0">
+              <a:rPr lang="en-US" sz="1500" b="1" dirty="0">
                 <a:solidFill>
                   <a:srgbClr val="3A4A2E"/>
                 </a:solidFill>
@@ -9739,16 +9807,16 @@
                 <a:ea typeface="Calibri" pitchFamily="34" charset="-122"/>
                 <a:cs typeface="Calibri" pitchFamily="34" charset="-120"/>
               </a:rPr>
-              <a:t>Honest finding.  </a:t>
+              <a:t>Honest caveat (Sarat).  </a:t>
             </a:r>
             <a:pPr algn="l" indent="0" marL="0">
               <a:lnSpc>
-                <a:spcPct val="120000"/>
+                <a:spcPct val="115000"/>
               </a:lnSpc>
               <a:buNone/>
             </a:pPr>
             <a:r>
-              <a:rPr lang="en-US" sz="1600" dirty="0">
+              <a:rPr lang="en-US" sz="1500" dirty="0">
                 <a:solidFill>
                   <a:srgbClr val="2B211A"/>
                 </a:solidFill>
@@ -9756,9 +9824,48 @@
                 <a:ea typeface="Calibri" pitchFamily="34" charset="-122"/>
                 <a:cs typeface="Calibri" pitchFamily="34" charset="-120"/>
               </a:rPr>
-              <a:t>On this ODE the exact closed-form solve on the GPU is actually faster than the NN. The NN only beats a general solver (~9.5×); the huge scipy number is hardware. Speed is not the win here.</a:t>
-            </a:r>
-            <a:endParaRPr lang="en-US" sz="1600" dirty="0"/>
+              <a:t>Any empirical model beats a mechanistic flux-balance simulation, so this is expected. COSMIC-dFBA's niche is mechanistic insight; the speed enables real-time use, it is not the contribution.</a:t>
+            </a:r>
+            <a:endParaRPr lang="en-US" sz="1500" dirty="0"/>
+          </a:p>
+        </p:txBody>
+      </p:sp>
+      <p:sp>
+        <p:nvSpPr>
+          <p:cNvPr id="6" name="Text 4"/>
+          <p:cNvSpPr/>
+          <p:nvPr/>
+        </p:nvSpPr>
+        <p:spPr>
+          <a:xfrm>
+            <a:off x="6400800" y="1645920"/>
+            <a:ext cx="5212080" cy="640080"/>
+          </a:xfrm>
+          <a:prstGeom prst="rect">
+            <a:avLst/>
+          </a:prstGeom>
+          <a:noFill/>
+          <a:ln/>
+        </p:spPr>
+        <p:txBody>
+          <a:bodyPr wrap="square" lIns="0" tIns="0" rIns="0" bIns="0" rtlCol="0" anchor="t"/>
+          <a:lstStyle/>
+          <a:p>
+            <a:pPr algn="l" indent="0" marL="0">
+              <a:buNone/>
+            </a:pPr>
+            <a:r>
+              <a:rPr lang="en-US" sz="1200" i="1" dirty="0">
+                <a:solidFill>
+                  <a:srgbClr val="7A6E5A"/>
+                </a:solidFill>
+                <a:latin typeface="Calibri" pitchFamily="34" charset="0"/>
+                <a:ea typeface="Calibri" pitchFamily="34" charset="-122"/>
+                <a:cs typeface="Calibri" pitchFamily="34" charset="-120"/>
+              </a:rPr>
+              <a:t>A separate comparison: our fast synthetic generator (a simplified ODE, what we train on), not COSMIC-dFBA:</a:t>
+            </a:r>
+            <a:endParaRPr lang="en-US" sz="1200" dirty="0"/>
           </a:p>
         </p:txBody>
       </p:sp>
@@ -9777,20 +9884,19 @@
           </p:nvPr>
         </p:nvGraphicFramePr>
         <p:xfrm>
-          <a:off x="6400800" y="2286000"/>
-          <a:ext cx="5303520" cy="914400"/>
+          <a:off x="6400800" y="2468880"/>
+          <a:ext cx="5212080" cy="914400"/>
         </p:xfrm>
         <a:graphic>
           <a:graphicData uri="http://schemas.openxmlformats.org/drawingml/2006/table">
             <a:tbl>
               <a:tblPr/>
               <a:tblGrid>
-                <a:gridCol w="2651760"/>
-                <a:gridCol w="1005840"/>
-                <a:gridCol w="822960"/>
-                <a:gridCol w="822960"/>
+                <a:gridCol w="3017520"/>
+                <a:gridCol w="1097280"/>
+                <a:gridCol w="1097280"/>
               </a:tblGrid>
-              <a:tr h="566928">
+              <a:tr h="603504">
                 <a:tc>
                   <a:txBody>
                     <a:bodyPr/>
@@ -9995,76 +10101,8 @@
                     </a:solidFill>
                   </a:tcPr>
                 </a:tc>
-                <a:tc>
-                  <a:txBody>
-                    <a:bodyPr/>
-                    <a:lstStyle/>
-                    <a:p>
-                      <a:pPr algn="ctr" indent="0" marL="0">
-                        <a:buNone/>
-                      </a:pPr>
-                      <a:r>
-                        <a:rPr lang="en-US" sz="1250" b="1" dirty="0">
-                          <a:solidFill>
-                            <a:srgbClr val="F3ECD8"/>
-                          </a:solidFill>
-                          <a:latin typeface="Calibri" pitchFamily="34" charset="0"/>
-                          <a:ea typeface="Calibri" pitchFamily="34" charset="-122"/>
-                          <a:cs typeface="Calibri" pitchFamily="34" charset="-120"/>
-                        </a:rPr>
-                        <a:t>vs torchdiffeq</a:t>
-                      </a:r>
-                      <a:endParaRPr lang="en-US" sz="1250" dirty="0">
-                        <a:latin typeface="Calibri" charset="0"/>
-                        <a:ea typeface="Calibri" charset="0"/>
-                        <a:cs typeface="Calibri" charset="0"/>
-                      </a:endParaRPr>
-                    </a:p>
-                  </a:txBody>
-                  <a:tcPr marL="91440" marR="91440" marT="45720" marB="45720" anchor="ctr">
-                    <a:lnL w="12700" cap="flat" cmpd="sng" algn="ctr">
-                      <a:solidFill>
-                        <a:srgbClr val="E6DEC9"/>
-                      </a:solidFill>
-                      <a:prstDash val="solid"/>
-                      <a:round/>
-                      <a:headEnd type="none" w="med" len="med"/>
-                      <a:tailEnd type="none" w="med" len="med"/>
-                    </a:lnL>
-                    <a:lnR w="12700" cap="flat" cmpd="sng" algn="ctr">
-                      <a:solidFill>
-                        <a:srgbClr val="E6DEC9"/>
-                      </a:solidFill>
-                      <a:prstDash val="solid"/>
-                      <a:round/>
-                      <a:headEnd type="none" w="med" len="med"/>
-                      <a:tailEnd type="none" w="med" len="med"/>
-                    </a:lnR>
-                    <a:lnT w="12700" cap="flat" cmpd="sng" algn="ctr">
-                      <a:solidFill>
-                        <a:srgbClr val="E6DEC9"/>
-                      </a:solidFill>
-                      <a:prstDash val="solid"/>
-                      <a:round/>
-                      <a:headEnd type="none" w="med" len="med"/>
-                      <a:tailEnd type="none" w="med" len="med"/>
-                    </a:lnT>
-                    <a:lnB w="12700" cap="flat" cmpd="sng" algn="ctr">
-                      <a:solidFill>
-                        <a:srgbClr val="E6DEC9"/>
-                      </a:solidFill>
-                      <a:prstDash val="solid"/>
-                      <a:round/>
-                      <a:headEnd type="none" w="med" len="med"/>
-                      <a:tailEnd type="none" w="med" len="med"/>
-                    </a:lnB>
-                    <a:solidFill>
-                      <a:srgbClr val="6B2333"/>
-                    </a:solidFill>
-                  </a:tcPr>
-                </a:tc>
               </a:tr>
-              <a:tr h="566928">
+              <a:tr h="603504">
                 <a:tc>
                   <a:txBody>
                     <a:bodyPr/>
@@ -10269,350 +10307,8 @@
                     </a:solidFill>
                   </a:tcPr>
                 </a:tc>
-                <a:tc>
-                  <a:txBody>
-                    <a:bodyPr/>
-                    <a:lstStyle/>
-                    <a:p>
-                      <a:pPr algn="ctr" indent="0" marL="0">
-                        <a:buNone/>
-                      </a:pPr>
-                      <a:r>
-                        <a:rPr lang="en-US" sz="1250" dirty="0">
-                          <a:solidFill>
-                            <a:srgbClr val="7A6E5A"/>
-                          </a:solidFill>
-                          <a:latin typeface="Calibri" pitchFamily="34" charset="0"/>
-                          <a:ea typeface="Calibri" pitchFamily="34" charset="-122"/>
-                          <a:cs typeface="Calibri" pitchFamily="34" charset="-120"/>
-                        </a:rPr>
-                        <a:t>—</a:t>
-                      </a:r>
-                      <a:endParaRPr lang="en-US" sz="1250" dirty="0">
-                        <a:latin typeface="Calibri" charset="0"/>
-                        <a:ea typeface="Calibri" charset="0"/>
-                        <a:cs typeface="Calibri" charset="0"/>
-                      </a:endParaRPr>
-                    </a:p>
-                  </a:txBody>
-                  <a:tcPr marL="91440" marR="91440" marT="45720" marB="45720" anchor="ctr">
-                    <a:lnL w="12700" cap="flat" cmpd="sng" algn="ctr">
-                      <a:solidFill>
-                        <a:srgbClr val="E6DEC9"/>
-                      </a:solidFill>
-                      <a:prstDash val="solid"/>
-                      <a:round/>
-                      <a:headEnd type="none" w="med" len="med"/>
-                      <a:tailEnd type="none" w="med" len="med"/>
-                    </a:lnL>
-                    <a:lnR w="12700" cap="flat" cmpd="sng" algn="ctr">
-                      <a:solidFill>
-                        <a:srgbClr val="E6DEC9"/>
-                      </a:solidFill>
-                      <a:prstDash val="solid"/>
-                      <a:round/>
-                      <a:headEnd type="none" w="med" len="med"/>
-                      <a:tailEnd type="none" w="med" len="med"/>
-                    </a:lnR>
-                    <a:lnT w="12700" cap="flat" cmpd="sng" algn="ctr">
-                      <a:solidFill>
-                        <a:srgbClr val="E6DEC9"/>
-                      </a:solidFill>
-                      <a:prstDash val="solid"/>
-                      <a:round/>
-                      <a:headEnd type="none" w="med" len="med"/>
-                      <a:tailEnd type="none" w="med" len="med"/>
-                    </a:lnT>
-                    <a:lnB w="12700" cap="flat" cmpd="sng" algn="ctr">
-                      <a:solidFill>
-                        <a:srgbClr val="E6DEC9"/>
-                      </a:solidFill>
-                      <a:prstDash val="solid"/>
-                      <a:round/>
-                      <a:headEnd type="none" w="med" len="med"/>
-                      <a:tailEnd type="none" w="med" len="med"/>
-                    </a:lnB>
-                    <a:solidFill>
-                      <a:srgbClr val="FAF8F2"/>
-                    </a:solidFill>
-                  </a:tcPr>
-                </a:tc>
               </a:tr>
-              <a:tr h="566928">
-                <a:tc>
-                  <a:txBody>
-                    <a:bodyPr/>
-                    <a:lstStyle/>
-                    <a:p>
-                      <a:pPr algn="l" indent="0" marL="0">
-                        <a:buNone/>
-                      </a:pPr>
-                      <a:r>
-                        <a:rPr lang="en-US" sz="1250" dirty="0">
-                          <a:solidFill>
-                            <a:srgbClr val="2B211A"/>
-                          </a:solidFill>
-                          <a:latin typeface="Calibri" pitchFamily="34" charset="0"/>
-                          <a:ea typeface="Calibri" pitchFamily="34" charset="-122"/>
-                          <a:cs typeface="Calibri" pitchFamily="34" charset="-120"/>
-                        </a:rPr>
-                        <a:t>torchdiffeq (GPU)</a:t>
-                      </a:r>
-                      <a:endParaRPr lang="en-US" sz="1250" dirty="0">
-                        <a:latin typeface="Calibri" charset="0"/>
-                        <a:ea typeface="Calibri" charset="0"/>
-                        <a:cs typeface="Calibri" charset="0"/>
-                      </a:endParaRPr>
-                    </a:p>
-                  </a:txBody>
-                  <a:tcPr marL="91440" marR="91440" marT="45720" marB="45720" anchor="ctr">
-                    <a:lnL w="12700" cap="flat" cmpd="sng" algn="ctr">
-                      <a:solidFill>
-                        <a:srgbClr val="E6DEC9"/>
-                      </a:solidFill>
-                      <a:prstDash val="solid"/>
-                      <a:round/>
-                      <a:headEnd type="none" w="med" len="med"/>
-                      <a:tailEnd type="none" w="med" len="med"/>
-                    </a:lnL>
-                    <a:lnR w="12700" cap="flat" cmpd="sng" algn="ctr">
-                      <a:solidFill>
-                        <a:srgbClr val="E6DEC9"/>
-                      </a:solidFill>
-                      <a:prstDash val="solid"/>
-                      <a:round/>
-                      <a:headEnd type="none" w="med" len="med"/>
-                      <a:tailEnd type="none" w="med" len="med"/>
-                    </a:lnR>
-                    <a:lnT w="12700" cap="flat" cmpd="sng" algn="ctr">
-                      <a:solidFill>
-                        <a:srgbClr val="E6DEC9"/>
-                      </a:solidFill>
-                      <a:prstDash val="solid"/>
-                      <a:round/>
-                      <a:headEnd type="none" w="med" len="med"/>
-                      <a:tailEnd type="none" w="med" len="med"/>
-                    </a:lnT>
-                    <a:lnB w="12700" cap="flat" cmpd="sng" algn="ctr">
-                      <a:solidFill>
-                        <a:srgbClr val="E6DEC9"/>
-                      </a:solidFill>
-                      <a:prstDash val="solid"/>
-                      <a:round/>
-                      <a:headEnd type="none" w="med" len="med"/>
-                      <a:tailEnd type="none" w="med" len="med"/>
-                    </a:lnB>
-                    <a:solidFill>
-                      <a:srgbClr val="FAF8F2"/>
-                    </a:solidFill>
-                  </a:tcPr>
-                </a:tc>
-                <a:tc>
-                  <a:txBody>
-                    <a:bodyPr/>
-                    <a:lstStyle/>
-                    <a:p>
-                      <a:pPr algn="ctr" indent="0" marL="0">
-                        <a:buNone/>
-                      </a:pPr>
-                      <a:r>
-                        <a:rPr lang="en-US" sz="1250" dirty="0">
-                          <a:solidFill>
-                            <a:srgbClr val="2B211A"/>
-                          </a:solidFill>
-                          <a:latin typeface="Calibri" pitchFamily="34" charset="0"/>
-                          <a:ea typeface="Calibri" pitchFamily="34" charset="-122"/>
-                          <a:cs typeface="Calibri" pitchFamily="34" charset="-120"/>
-                        </a:rPr>
-                        <a:t>0.013</a:t>
-                      </a:r>
-                      <a:endParaRPr lang="en-US" sz="1250" dirty="0">
-                        <a:latin typeface="Calibri" charset="0"/>
-                        <a:ea typeface="Calibri" charset="0"/>
-                        <a:cs typeface="Calibri" charset="0"/>
-                      </a:endParaRPr>
-                    </a:p>
-                  </a:txBody>
-                  <a:tcPr marL="91440" marR="91440" marT="45720" marB="45720" anchor="ctr">
-                    <a:lnL w="12700" cap="flat" cmpd="sng" algn="ctr">
-                      <a:solidFill>
-                        <a:srgbClr val="E6DEC9"/>
-                      </a:solidFill>
-                      <a:prstDash val="solid"/>
-                      <a:round/>
-                      <a:headEnd type="none" w="med" len="med"/>
-                      <a:tailEnd type="none" w="med" len="med"/>
-                    </a:lnL>
-                    <a:lnR w="12700" cap="flat" cmpd="sng" algn="ctr">
-                      <a:solidFill>
-                        <a:srgbClr val="E6DEC9"/>
-                      </a:solidFill>
-                      <a:prstDash val="solid"/>
-                      <a:round/>
-                      <a:headEnd type="none" w="med" len="med"/>
-                      <a:tailEnd type="none" w="med" len="med"/>
-                    </a:lnR>
-                    <a:lnT w="12700" cap="flat" cmpd="sng" algn="ctr">
-                      <a:solidFill>
-                        <a:srgbClr val="E6DEC9"/>
-                      </a:solidFill>
-                      <a:prstDash val="solid"/>
-                      <a:round/>
-                      <a:headEnd type="none" w="med" len="med"/>
-                      <a:tailEnd type="none" w="med" len="med"/>
-                    </a:lnT>
-                    <a:lnB w="12700" cap="flat" cmpd="sng" algn="ctr">
-                      <a:solidFill>
-                        <a:srgbClr val="E6DEC9"/>
-                      </a:solidFill>
-                      <a:prstDash val="solid"/>
-                      <a:round/>
-                      <a:headEnd type="none" w="med" len="med"/>
-                      <a:tailEnd type="none" w="med" len="med"/>
-                    </a:lnB>
-                    <a:solidFill>
-                      <a:srgbClr val="FAF8F2"/>
-                    </a:solidFill>
-                  </a:tcPr>
-                </a:tc>
-                <a:tc>
-                  <a:txBody>
-                    <a:bodyPr/>
-                    <a:lstStyle/>
-                    <a:p>
-                      <a:pPr algn="ctr" indent="0" marL="0">
-                        <a:buNone/>
-                      </a:pPr>
-                      <a:r>
-                        <a:rPr lang="en-US" sz="1250" dirty="0">
-                          <a:solidFill>
-                            <a:srgbClr val="2B211A"/>
-                          </a:solidFill>
-                          <a:latin typeface="Calibri" pitchFamily="34" charset="0"/>
-                          <a:ea typeface="Calibri" pitchFamily="34" charset="-122"/>
-                          <a:cs typeface="Calibri" pitchFamily="34" charset="-120"/>
-                        </a:rPr>
-                        <a:t>2,000×</a:t>
-                      </a:r>
-                      <a:endParaRPr lang="en-US" sz="1250" dirty="0">
-                        <a:latin typeface="Calibri" charset="0"/>
-                        <a:ea typeface="Calibri" charset="0"/>
-                        <a:cs typeface="Calibri" charset="0"/>
-                      </a:endParaRPr>
-                    </a:p>
-                  </a:txBody>
-                  <a:tcPr marL="91440" marR="91440" marT="45720" marB="45720" anchor="ctr">
-                    <a:lnL w="12700" cap="flat" cmpd="sng" algn="ctr">
-                      <a:solidFill>
-                        <a:srgbClr val="E6DEC9"/>
-                      </a:solidFill>
-                      <a:prstDash val="solid"/>
-                      <a:round/>
-                      <a:headEnd type="none" w="med" len="med"/>
-                      <a:tailEnd type="none" w="med" len="med"/>
-                    </a:lnL>
-                    <a:lnR w="12700" cap="flat" cmpd="sng" algn="ctr">
-                      <a:solidFill>
-                        <a:srgbClr val="E6DEC9"/>
-                      </a:solidFill>
-                      <a:prstDash val="solid"/>
-                      <a:round/>
-                      <a:headEnd type="none" w="med" len="med"/>
-                      <a:tailEnd type="none" w="med" len="med"/>
-                    </a:lnR>
-                    <a:lnT w="12700" cap="flat" cmpd="sng" algn="ctr">
-                      <a:solidFill>
-                        <a:srgbClr val="E6DEC9"/>
-                      </a:solidFill>
-                      <a:prstDash val="solid"/>
-                      <a:round/>
-                      <a:headEnd type="none" w="med" len="med"/>
-                      <a:tailEnd type="none" w="med" len="med"/>
-                    </a:lnT>
-                    <a:lnB w="12700" cap="flat" cmpd="sng" algn="ctr">
-                      <a:solidFill>
-                        <a:srgbClr val="E6DEC9"/>
-                      </a:solidFill>
-                      <a:prstDash val="solid"/>
-                      <a:round/>
-                      <a:headEnd type="none" w="med" len="med"/>
-                      <a:tailEnd type="none" w="med" len="med"/>
-                    </a:lnB>
-                    <a:solidFill>
-                      <a:srgbClr val="FAF8F2"/>
-                    </a:solidFill>
-                  </a:tcPr>
-                </a:tc>
-                <a:tc>
-                  <a:txBody>
-                    <a:bodyPr/>
-                    <a:lstStyle/>
-                    <a:p>
-                      <a:pPr algn="ctr" indent="0" marL="0">
-                        <a:buNone/>
-                      </a:pPr>
-                      <a:r>
-                        <a:rPr lang="en-US" sz="1250" b="1" dirty="0">
-                          <a:solidFill>
-                            <a:srgbClr val="3A4A2E"/>
-                          </a:solidFill>
-                          <a:latin typeface="Calibri" pitchFamily="34" charset="0"/>
-                          <a:ea typeface="Calibri" pitchFamily="34" charset="-122"/>
-                          <a:cs typeface="Calibri" pitchFamily="34" charset="-120"/>
-                        </a:rPr>
-                        <a:t>1×</a:t>
-                      </a:r>
-                      <a:endParaRPr lang="en-US" sz="1250" dirty="0">
-                        <a:latin typeface="Calibri" charset="0"/>
-                        <a:ea typeface="Calibri" charset="0"/>
-                        <a:cs typeface="Calibri" charset="0"/>
-                      </a:endParaRPr>
-                    </a:p>
-                  </a:txBody>
-                  <a:tcPr marL="91440" marR="91440" marT="45720" marB="45720" anchor="ctr">
-                    <a:lnL w="12700" cap="flat" cmpd="sng" algn="ctr">
-                      <a:solidFill>
-                        <a:srgbClr val="E6DEC9"/>
-                      </a:solidFill>
-                      <a:prstDash val="solid"/>
-                      <a:round/>
-                      <a:headEnd type="none" w="med" len="med"/>
-                      <a:tailEnd type="none" w="med" len="med"/>
-                    </a:lnL>
-                    <a:lnR w="12700" cap="flat" cmpd="sng" algn="ctr">
-                      <a:solidFill>
-                        <a:srgbClr val="E6DEC9"/>
-                      </a:solidFill>
-                      <a:prstDash val="solid"/>
-                      <a:round/>
-                      <a:headEnd type="none" w="med" len="med"/>
-                      <a:tailEnd type="none" w="med" len="med"/>
-                    </a:lnR>
-                    <a:lnT w="12700" cap="flat" cmpd="sng" algn="ctr">
-                      <a:solidFill>
-                        <a:srgbClr val="E6DEC9"/>
-                      </a:solidFill>
-                      <a:prstDash val="solid"/>
-                      <a:round/>
-                      <a:headEnd type="none" w="med" len="med"/>
-                      <a:tailEnd type="none" w="med" len="med"/>
-                    </a:lnT>
-                    <a:lnB w="12700" cap="flat" cmpd="sng" algn="ctr">
-                      <a:solidFill>
-                        <a:srgbClr val="E6DEC9"/>
-                      </a:solidFill>
-                      <a:prstDash val="solid"/>
-                      <a:round/>
-                      <a:headEnd type="none" w="med" len="med"/>
-                      <a:tailEnd type="none" w="med" len="med"/>
-                    </a:lnB>
-                    <a:solidFill>
-                      <a:srgbClr val="FAF8F2"/>
-                    </a:solidFill>
-                  </a:tcPr>
-                </a:tc>
-              </a:tr>
-              <a:tr h="566928">
+              <a:tr h="603504">
                 <a:tc>
                   <a:txBody>
                     <a:bodyPr/>
@@ -10817,76 +10513,8 @@
                     </a:solidFill>
                   </a:tcPr>
                 </a:tc>
-                <a:tc>
-                  <a:txBody>
-                    <a:bodyPr/>
-                    <a:lstStyle/>
-                    <a:p>
-                      <a:pPr algn="ctr" indent="0" marL="0">
-                        <a:buNone/>
-                      </a:pPr>
-                      <a:r>
-                        <a:rPr lang="en-US" sz="1250" b="1" dirty="0">
-                          <a:solidFill>
-                            <a:srgbClr val="3A4A2E"/>
-                          </a:solidFill>
-                          <a:latin typeface="Calibri" pitchFamily="34" charset="0"/>
-                          <a:ea typeface="Calibri" pitchFamily="34" charset="-122"/>
-                          <a:cs typeface="Calibri" pitchFamily="34" charset="-120"/>
-                        </a:rPr>
-                        <a:t>24×</a:t>
-                      </a:r>
-                      <a:endParaRPr lang="en-US" sz="1250" dirty="0">
-                        <a:latin typeface="Calibri" charset="0"/>
-                        <a:ea typeface="Calibri" charset="0"/>
-                        <a:cs typeface="Calibri" charset="0"/>
-                      </a:endParaRPr>
-                    </a:p>
-                  </a:txBody>
-                  <a:tcPr marL="91440" marR="91440" marT="45720" marB="45720" anchor="ctr">
-                    <a:lnL w="12700" cap="flat" cmpd="sng" algn="ctr">
-                      <a:solidFill>
-                        <a:srgbClr val="E6DEC9"/>
-                      </a:solidFill>
-                      <a:prstDash val="solid"/>
-                      <a:round/>
-                      <a:headEnd type="none" w="med" len="med"/>
-                      <a:tailEnd type="none" w="med" len="med"/>
-                    </a:lnL>
-                    <a:lnR w="12700" cap="flat" cmpd="sng" algn="ctr">
-                      <a:solidFill>
-                        <a:srgbClr val="E6DEC9"/>
-                      </a:solidFill>
-                      <a:prstDash val="solid"/>
-                      <a:round/>
-                      <a:headEnd type="none" w="med" len="med"/>
-                      <a:tailEnd type="none" w="med" len="med"/>
-                    </a:lnR>
-                    <a:lnT w="12700" cap="flat" cmpd="sng" algn="ctr">
-                      <a:solidFill>
-                        <a:srgbClr val="E6DEC9"/>
-                      </a:solidFill>
-                      <a:prstDash val="solid"/>
-                      <a:round/>
-                      <a:headEnd type="none" w="med" len="med"/>
-                      <a:tailEnd type="none" w="med" len="med"/>
-                    </a:lnT>
-                    <a:lnB w="12700" cap="flat" cmpd="sng" algn="ctr">
-                      <a:solidFill>
-                        <a:srgbClr val="E6DEC9"/>
-                      </a:solidFill>
-                      <a:prstDash val="solid"/>
-                      <a:round/>
-                      <a:headEnd type="none" w="med" len="med"/>
-                      <a:tailEnd type="none" w="med" len="med"/>
-                    </a:lnB>
-                    <a:solidFill>
-                      <a:srgbClr val="FAF8F2"/>
-                    </a:solidFill>
-                  </a:tcPr>
-                </a:tc>
               </a:tr>
-              <a:tr h="566928">
+              <a:tr h="603504">
                 <a:tc>
                   <a:txBody>
                     <a:bodyPr/>
@@ -10904,7 +10532,7 @@
                           <a:ea typeface="Calibri" pitchFamily="34" charset="-122"/>
                           <a:cs typeface="Calibri" pitchFamily="34" charset="-120"/>
                         </a:rPr>
-                        <a:t>pure NN (GPU, real net)</a:t>
+                        <a:t>pure NN (GPU, small)</a:t>
                       </a:r>
                       <a:endParaRPr lang="en-US" sz="1250" dirty="0">
                         <a:latin typeface="Calibri" charset="0"/>
@@ -10972,7 +10600,7 @@
                           <a:ea typeface="Calibri" pitchFamily="34" charset="-122"/>
                           <a:cs typeface="Calibri" pitchFamily="34" charset="-120"/>
                         </a:rPr>
-                        <a:t>0.0013</a:t>
+                        <a:t>0.0005</a:t>
                       </a:r>
                       <a:endParaRPr lang="en-US" sz="1250" dirty="0">
                         <a:latin typeface="Calibri" charset="0"/>
@@ -11040,75 +10668,7 @@
                           <a:ea typeface="Calibri" pitchFamily="34" charset="-122"/>
                           <a:cs typeface="Calibri" pitchFamily="34" charset="-120"/>
                         </a:rPr>
-                        <a:t>18,900×</a:t>
-                      </a:r>
-                      <a:endParaRPr lang="en-US" sz="1250" dirty="0">
-                        <a:latin typeface="Calibri" charset="0"/>
-                        <a:ea typeface="Calibri" charset="0"/>
-                        <a:cs typeface="Calibri" charset="0"/>
-                      </a:endParaRPr>
-                    </a:p>
-                  </a:txBody>
-                  <a:tcPr marL="91440" marR="91440" marT="45720" marB="45720" anchor="ctr">
-                    <a:lnL w="12700" cap="flat" cmpd="sng" algn="ctr">
-                      <a:solidFill>
-                        <a:srgbClr val="E6DEC9"/>
-                      </a:solidFill>
-                      <a:prstDash val="solid"/>
-                      <a:round/>
-                      <a:headEnd type="none" w="med" len="med"/>
-                      <a:tailEnd type="none" w="med" len="med"/>
-                    </a:lnL>
-                    <a:lnR w="12700" cap="flat" cmpd="sng" algn="ctr">
-                      <a:solidFill>
-                        <a:srgbClr val="E6DEC9"/>
-                      </a:solidFill>
-                      <a:prstDash val="solid"/>
-                      <a:round/>
-                      <a:headEnd type="none" w="med" len="med"/>
-                      <a:tailEnd type="none" w="med" len="med"/>
-                    </a:lnR>
-                    <a:lnT w="12700" cap="flat" cmpd="sng" algn="ctr">
-                      <a:solidFill>
-                        <a:srgbClr val="E6DEC9"/>
-                      </a:solidFill>
-                      <a:prstDash val="solid"/>
-                      <a:round/>
-                      <a:headEnd type="none" w="med" len="med"/>
-                      <a:tailEnd type="none" w="med" len="med"/>
-                    </a:lnT>
-                    <a:lnB w="12700" cap="flat" cmpd="sng" algn="ctr">
-                      <a:solidFill>
-                        <a:srgbClr val="E6DEC9"/>
-                      </a:solidFill>
-                      <a:prstDash val="solid"/>
-                      <a:round/>
-                      <a:headEnd type="none" w="med" len="med"/>
-                      <a:tailEnd type="none" w="med" len="med"/>
-                    </a:lnB>
-                    <a:solidFill>
-                      <a:srgbClr val="FAF8F2"/>
-                    </a:solidFill>
-                  </a:tcPr>
-                </a:tc>
-                <a:tc>
-                  <a:txBody>
-                    <a:bodyPr/>
-                    <a:lstStyle/>
-                    <a:p>
-                      <a:pPr algn="ctr" indent="0" marL="0">
-                        <a:buNone/>
-                      </a:pPr>
-                      <a:r>
-                        <a:rPr lang="en-US" sz="1250" b="1" dirty="0">
-                          <a:solidFill>
-                            <a:srgbClr val="6B2333"/>
-                          </a:solidFill>
-                          <a:latin typeface="Calibri" pitchFamily="34" charset="0"/>
-                          <a:ea typeface="Calibri" pitchFamily="34" charset="-122"/>
-                          <a:cs typeface="Calibri" pitchFamily="34" charset="-120"/>
-                        </a:rPr>
-                        <a:t>9.5×</a:t>
+                        <a:t>47,000×</a:t>
                       </a:r>
                       <a:endParaRPr lang="en-US" sz="1250" dirty="0">
                         <a:latin typeface="Calibri" charset="0"/>
@@ -11166,14 +10726,14 @@
       </p:graphicFrame>
       <p:sp>
         <p:nvSpPr>
-          <p:cNvPr id="6" name="Text 3"/>
+          <p:cNvPr id="8" name="Text 5"/>
           <p:cNvSpPr/>
           <p:nvPr/>
         </p:nvSpPr>
         <p:spPr>
           <a:xfrm>
-            <a:off x="6400800" y="5166360"/>
-            <a:ext cx="5303520" cy="640080"/>
+            <a:off x="6400800" y="5074920"/>
+            <a:ext cx="5212080" cy="822960"/>
           </a:xfrm>
           <a:prstGeom prst="rect">
             <a:avLst/>
@@ -11197,7 +10757,7 @@
                 <a:ea typeface="Calibri" pitchFamily="34" charset="-122"/>
                 <a:cs typeface="Calibri" pitchFamily="34" charset="-120"/>
               </a:rPr>
-              <a:t>A100, n = 20,000, sustained loop. NN = real model (hidden 64, 3 conv). Green: the closed-form ODE beats the NN.</a:t>
+              <a:t>A100, n = 20,000, small net (1 conv, hidden 32). The NN ties the exact closed-form ODE; this is our simplified generator, COSMIC-dFBA (~15 min) is off this chart entirely.</a:t>
             </a:r>
             <a:endParaRPr lang="en-US" sz="1100" dirty="0"/>
           </a:p>

</xml_diff>

<commit_message>
Condense nn/ to the essential pipeline: move 19 out-of-scope files to scripts_past
Kept: model, nn_baseline, evaluate, model_primeur, generate_synthetic_ode,
compute_aa_scales, device_utils (+ speed_benchmark, pinn_baseline for the deck).
Moved fed-batch, real-data-training/LORO, and old experiments. Made the
rate_envelope import lazy (only used with --sample-rates) so the default
generate path needs no moved files.

Co-Authored-By: Claude Opus 4.8 <noreply@anthropic.com>
</commit_message>
<xml_diff>
--- a/en_primeur_lab_meeting.pptx
+++ b/en_primeur_lab_meeting.pptx
@@ -14139,7 +14139,7 @@
                 <a:ea typeface="Calibri" pitchFamily="34" charset="-122"/>
                 <a:cs typeface="Calibri" pitchFamily="34" charset="-120"/>
               </a:rPr>
-              <a:t>Black = the true run.  Red dashed = the NN's forecast.  </a:t>
+              <a:t>Black = the synthetic ODE run (our ground truth).  Red dashed = the NN's forecast.  </a:t>
             </a:r>
             <a:pPr algn="l" indent="0" marL="0">
               <a:lnSpc>
@@ -14156,7 +14156,7 @@
                 <a:ea typeface="Calibri" pitchFamily="34" charset="-122"/>
                 <a:cs typeface="Calibri" pitchFamily="34" charset="-120"/>
               </a:rPr>
-              <a:t>The model sees only days 0–6 (left of the line), then predicts the peak and decline of days 6–12 on its own. R² 0.97.</a:t>
+              <a:t>The model sees only days 0–6 (left of the line), then predicts the peak and decline of days 6–12 on its own. R² 0.95. No real data is used, we test whether the NN reproduces the simulator.</a:t>
             </a:r>
             <a:endParaRPr lang="en-US" sz="1450" dirty="0"/>
           </a:p>

</xml_diff>